<commit_message>
Deck: title and team-details slides filled with project title, problem statement and repo link
</commit_message>
<xml_diff>
--- a/docs/sample.pptx
+++ b/docs/sample.pptx
@@ -3462,7 +3462,7 @@
               </a:defRPr>
             </a:pPr>
             <a:r>
-              <a:t>[PROJECT TITLE]     |     [TEAM NAME / TEAM ID]</a:t>
+              <a:t>VINDEX: AI GRIEVANCE REDRESSAL PRIORITIZATION SYSTEM     |     [TEAM NAME / TEAM ID]</a:t>
             </a:r>
           </a:p>
         </p:txBody>
@@ -5153,7 +5153,7 @@
               </a:defRPr>
             </a:pPr>
             <a:r>
-              <a:t>•  Project Title: [Enter title]</a:t>
+              <a:t>•  Project Title: Vindex, an AI Grievance Redressal Prioritization System (multilingual, local-AI complaint triage)</a:t>
             </a:r>
           </a:p>
           <a:p>
@@ -5169,7 +5169,7 @@
               </a:defRPr>
             </a:pPr>
             <a:r>
-              <a:t>•  Team Name / Team ID: [Enter details]</a:t>
+              <a:t>•  Team Name / Team ID: [Enter team name and ID]</a:t>
             </a:r>
           </a:p>
           <a:p>
@@ -5185,7 +5185,7 @@
               </a:defRPr>
             </a:pPr>
             <a:r>
-              <a:t>•  Problem Statement ID and Title: [Enter details]</a:t>
+              <a:t>•  Problem Statement ID and Title: [PS ID], AI Grievance Redressal Prioritization System</a:t>
             </a:r>
           </a:p>
           <a:p>
@@ -5201,21 +5201,7 @@
               </a:defRPr>
             </a:pPr>
             <a:r>
-              <a:t>•  Team </a:t>
-            </a:r>
-            <a:r>
-              <a:rPr lang="en-US"/>
-              <a:t>Leader</a:t>
-            </a:r>
-            <a:r>
-              <a:t>: [Name — Register Number; </a:t>
-            </a:r>
-            <a:r>
-              <a:rPr lang="en-US"/>
-              <a:t>Dept,Year,Section</a:t>
-            </a:r>
-            <a:r>
-              <a:t>]</a:t>
+              <a:t>•  Team Leader: [Name, Register Number; Dept, Year, Section]</a:t>
             </a:r>
           </a:p>
           <a:p>
@@ -5231,7 +5217,7 @@
               </a:defRPr>
             </a:pPr>
             <a:r>
-              <a:t>•  Project Repository / Demo Link: [URL or Not Available]</a:t>
+              <a:t>•  Project Repository / Demo Link: github.com/Balavigneshcse/AI_Grievance_Redressal_Prioritization_System; demo runs locally on the team laptop (not hosted)</a:t>
             </a:r>
           </a:p>
         </p:txBody>

</xml_diff>

<commit_message>
Round-2 training results: 940 synthetic complaints, retrained classifier, gold-set replay, docs and deck updated
Second generation round added 477 complaints (none dropped), 940 synthetic rows in all.
Classifier retrained on 1,163 rows: department 0.846 held-out (en 0.91, hi 0.89,
ta-en 0.85, hi-en 0.78, ta 0.73), urgency 0.55. Gold set unchanged: system with
rules 1.00 department, 0.92 urgency, 1.00 critical recall, 0.92 language ID, 11.5 s
per complaint. Test report section 9, runbook numbers, implementation doc and deck
slide 6 updated.
</commit_message>
<xml_diff>
--- a/docs/sample.pptx
+++ b/docs/sample.pptx
@@ -15755,7 +15755,7 @@
                 </a:solidFill>
                 <a:latin typeface="Aptos"/>
               </a:rPr>
-              <a:t>trained on 460 locally generated complaints; YAML rules; script-based language hints</a:t>
+              <a:t>trained on 940 locally generated complaints (85% department held-out); YAML rules; language hints</a:t>
             </a:r>
           </a:p>
           <a:p>
@@ -16300,7 +16300,7 @@
                 </a:solidFill>
                 <a:latin typeface="Aptos"/>
               </a:rPr>
-              <a:t>Mailpit for demo email, Gmail SMTP optional, 61-check end-to-end test suite</a:t>
+              <a:t>Mailpit for demo email, Gmail SMTP optional, 91-check end-to-end test suite</a:t>
             </a:r>
           </a:p>
         </p:txBody>

</xml_diff>